<commit_message>
Revised professor's title to Dr.
</commit_message>
<xml_diff>
--- a/progress report/final_report/Final_Presentation_Slides_Revised.pptx
+++ b/progress report/final_report/Final_Presentation_Slides_Revised.pptx
@@ -4841,7 +4841,7 @@
           <a:p>
             <a:fld id="{31FEC60F-5E3D-0C4B-AF18-8AC772BEA507}" type="datetimeFigureOut">
               <a:rPr lang="en-US" smtClean="0"/>
-              <a:t>8/15/26</a:t>
+              <a:t>8/17/26</a:t>
             </a:fld>
             <a:endParaRPr lang="en-US"/>
           </a:p>
@@ -8532,7 +8532,7 @@
           <a:p>
             <a:fld id="{5BCAD085-E8A6-8845-BD4E-CB4CCA059FC4}" type="datetimeFigureOut">
               <a:rPr lang="en-US" smtClean="0"/>
-              <a:t>8/15/26</a:t>
+              <a:t>8/17/26</a:t>
             </a:fld>
             <a:endParaRPr lang="en-US"/>
           </a:p>
@@ -8700,7 +8700,7 @@
           <a:p>
             <a:fld id="{5BCAD085-E8A6-8845-BD4E-CB4CCA059FC4}" type="datetimeFigureOut">
               <a:rPr lang="en-US" smtClean="0"/>
-              <a:t>8/15/26</a:t>
+              <a:t>8/17/26</a:t>
             </a:fld>
             <a:endParaRPr lang="en-US"/>
           </a:p>
@@ -8878,7 +8878,7 @@
           <a:p>
             <a:fld id="{5BCAD085-E8A6-8845-BD4E-CB4CCA059FC4}" type="datetimeFigureOut">
               <a:rPr lang="en-US" smtClean="0"/>
-              <a:t>8/15/26</a:t>
+              <a:t>8/17/26</a:t>
             </a:fld>
             <a:endParaRPr lang="en-US"/>
           </a:p>
@@ -9046,7 +9046,7 @@
           <a:p>
             <a:fld id="{5BCAD085-E8A6-8845-BD4E-CB4CCA059FC4}" type="datetimeFigureOut">
               <a:rPr lang="en-US" smtClean="0"/>
-              <a:t>8/15/26</a:t>
+              <a:t>8/17/26</a:t>
             </a:fld>
             <a:endParaRPr lang="en-US"/>
           </a:p>
@@ -9291,7 +9291,7 @@
           <a:p>
             <a:fld id="{5BCAD085-E8A6-8845-BD4E-CB4CCA059FC4}" type="datetimeFigureOut">
               <a:rPr lang="en-US" smtClean="0"/>
-              <a:t>8/15/26</a:t>
+              <a:t>8/17/26</a:t>
             </a:fld>
             <a:endParaRPr lang="en-US"/>
           </a:p>
@@ -9576,7 +9576,7 @@
           <a:p>
             <a:fld id="{5BCAD085-E8A6-8845-BD4E-CB4CCA059FC4}" type="datetimeFigureOut">
               <a:rPr lang="en-US" smtClean="0"/>
-              <a:t>8/15/26</a:t>
+              <a:t>8/17/26</a:t>
             </a:fld>
             <a:endParaRPr lang="en-US"/>
           </a:p>
@@ -9995,7 +9995,7 @@
           <a:p>
             <a:fld id="{5BCAD085-E8A6-8845-BD4E-CB4CCA059FC4}" type="datetimeFigureOut">
               <a:rPr lang="en-US" smtClean="0"/>
-              <a:t>8/15/26</a:t>
+              <a:t>8/17/26</a:t>
             </a:fld>
             <a:endParaRPr lang="en-US"/>
           </a:p>
@@ -10112,7 +10112,7 @@
           <a:p>
             <a:fld id="{5BCAD085-E8A6-8845-BD4E-CB4CCA059FC4}" type="datetimeFigureOut">
               <a:rPr lang="en-US" smtClean="0"/>
-              <a:t>8/15/26</a:t>
+              <a:t>8/17/26</a:t>
             </a:fld>
             <a:endParaRPr lang="en-US"/>
           </a:p>
@@ -10207,7 +10207,7 @@
           <a:p>
             <a:fld id="{5BCAD085-E8A6-8845-BD4E-CB4CCA059FC4}" type="datetimeFigureOut">
               <a:rPr lang="en-US" smtClean="0"/>
-              <a:t>8/15/26</a:t>
+              <a:t>8/17/26</a:t>
             </a:fld>
             <a:endParaRPr lang="en-US"/>
           </a:p>
@@ -10482,7 +10482,7 @@
           <a:p>
             <a:fld id="{5BCAD085-E8A6-8845-BD4E-CB4CCA059FC4}" type="datetimeFigureOut">
               <a:rPr lang="en-US" smtClean="0"/>
-              <a:t>8/15/26</a:t>
+              <a:t>8/17/26</a:t>
             </a:fld>
             <a:endParaRPr lang="en-US"/>
           </a:p>
@@ -10734,7 +10734,7 @@
           <a:p>
             <a:fld id="{5BCAD085-E8A6-8845-BD4E-CB4CCA059FC4}" type="datetimeFigureOut">
               <a:rPr lang="en-US" smtClean="0"/>
-              <a:t>8/15/26</a:t>
+              <a:t>8/17/26</a:t>
             </a:fld>
             <a:endParaRPr lang="en-US"/>
           </a:p>
@@ -10945,7 +10945,7 @@
           <a:p>
             <a:fld id="{5BCAD085-E8A6-8845-BD4E-CB4CCA059FC4}" type="datetimeFigureOut">
               <a:rPr lang="en-US" smtClean="0"/>
-              <a:t>8/15/26</a:t>
+              <a:t>8/17/26</a:t>
             </a:fld>
             <a:endParaRPr lang="en-US"/>
           </a:p>
@@ -11540,7 +11540,25 @@
                 </a:solidFill>
                 <a:latin typeface="Calibri"/>
               </a:rPr>
-              <a:t>Supervisor: Prof. </a:t>
+              <a:t>Supervisor: </a:t>
+            </a:r>
+            <a:r>
+              <a:rPr lang="en-CA" sz="1600">
+                <a:solidFill>
+                  <a:srgbClr val="4A5568"/>
+                </a:solidFill>
+                <a:latin typeface="Calibri"/>
+              </a:rPr>
+              <a:t>Dr</a:t>
+            </a:r>
+            <a:r>
+              <a:rPr sz="1600" b="0">
+                <a:solidFill>
+                  <a:srgbClr val="4A5568"/>
+                </a:solidFill>
+                <a:latin typeface="Calibri"/>
+              </a:rPr>
+              <a:t>. </a:t>
             </a:r>
             <a:r>
               <a:rPr sz="1600" b="0" dirty="0" err="1">

</xml_diff>